<commit_message>
Project - Router 까지 개발완료.
</commit_message>
<xml_diff>
--- a/doc/개발환경_설치매뉴얼(Vue.JS).pptx
+++ b/doc/개발환경_설치매뉴얼(Vue.JS).pptx
@@ -4006,7 +4006,7 @@
                   <a:srgbClr val="FF0000"/>
                 </a:solidFill>
               </a:rPr>
-              <a:t>/home</a:t>
+              <a:t>/</a:t>
             </a:r>
             <a:r>
               <a:rPr lang="en-US" altLang="ko-KR" sz="1000" dirty="0"/>
@@ -4042,6 +4042,42 @@
                   <a:srgbClr val="FF0000"/>
                 </a:solidFill>
               </a:rPr>
+              <a:t>/home</a:t>
+            </a:r>
+            <a:r>
+              <a:rPr lang="en-US" altLang="ko-KR" sz="1000" dirty="0"/>
+              <a:t>',  component: </a:t>
+            </a:r>
+            <a:r>
+              <a:rPr lang="en-US" altLang="ko-KR" sz="1000" dirty="0" err="1">
+                <a:solidFill>
+                  <a:srgbClr val="0070C0"/>
+                </a:solidFill>
+              </a:rPr>
+              <a:t>HomeView</a:t>
+            </a:r>
+            <a:r>
+              <a:rPr lang="en-US" altLang="ko-KR" sz="1000" dirty="0"/>
+              <a:t> },</a:t>
+            </a:r>
+          </a:p>
+          <a:p>
+            <a:pPr marL="342900" lvl="1" indent="0">
+              <a:lnSpc>
+                <a:spcPct val="50000"/>
+              </a:lnSpc>
+              <a:buNone/>
+            </a:pPr>
+            <a:r>
+              <a:rPr lang="en-US" altLang="ko-KR" sz="1000" dirty="0"/>
+              <a:t>    { path: '</a:t>
+            </a:r>
+            <a:r>
+              <a:rPr lang="en-US" altLang="ko-KR" sz="1000" dirty="0">
+                <a:solidFill>
+                  <a:srgbClr val="FF0000"/>
+                </a:solidFill>
+              </a:rPr>
               <a:t>/about</a:t>
             </a:r>
             <a:r>
@@ -4145,7 +4181,7 @@
             </a:pPr>
             <a:r>
               <a:rPr lang="en-US" altLang="ko-KR" sz="1000" dirty="0"/>
-              <a:t>        routes</a:t>
+              <a:t>        routes,</a:t>
             </a:r>
           </a:p>
           <a:p>
@@ -4157,7 +4193,7 @@
             </a:pPr>
             <a:r>
               <a:rPr lang="en-US" altLang="ko-KR" sz="1000" dirty="0"/>
-              <a:t>    }</a:t>
+              <a:t>    });</a:t>
             </a:r>
           </a:p>
           <a:p>
@@ -4167,10 +4203,7 @@
               </a:lnSpc>
               <a:buNone/>
             </a:pPr>
-            <a:r>
-              <a:rPr lang="en-US" altLang="ko-KR" sz="1000" dirty="0"/>
-              <a:t>);</a:t>
-            </a:r>
+            <a:endParaRPr lang="en-US" altLang="ko-KR" sz="1000" dirty="0"/>
           </a:p>
           <a:p>
             <a:pPr marL="342900" lvl="1" indent="0">
@@ -4303,7 +4336,7 @@
             </a:r>
             <a:r>
               <a:rPr lang="en-US" altLang="ko-KR" sz="1000" dirty="0"/>
-              <a:t> to="/"&gt;Home&lt;/</a:t>
+              <a:t> to=‘/’&gt;Home&lt;/</a:t>
             </a:r>
             <a:r>
               <a:rPr lang="en-US" altLang="ko-KR" sz="1000" dirty="0" err="1">
@@ -4339,7 +4372,7 @@
             </a:r>
             <a:r>
               <a:rPr lang="en-US" altLang="ko-KR" sz="1000" dirty="0"/>
-              <a:t> to="/about"&gt;About&lt;/</a:t>
+              <a:t> to=‘/about’&gt;About&lt;/</a:t>
             </a:r>
             <a:r>
               <a:rPr lang="en-US" altLang="ko-KR" sz="1000" dirty="0" err="1">
@@ -4362,6 +4395,59 @@
               <a:buNone/>
             </a:pPr>
             <a:r>
+              <a:rPr lang="it-IT" altLang="ko-KR" sz="1000" dirty="0">
+                <a:solidFill>
+                  <a:schemeClr val="accent5"/>
+                </a:solidFill>
+              </a:rPr>
+              <a:t>    &lt;button @click="this.$router.push('control')"&gt;sd&lt;/button&gt;</a:t>
+            </a:r>
+            <a:endParaRPr lang="en-US" altLang="ko-KR" sz="1000" dirty="0">
+              <a:solidFill>
+                <a:schemeClr val="accent5"/>
+              </a:solidFill>
+            </a:endParaRPr>
+          </a:p>
+          <a:p>
+            <a:pPr marL="342900" lvl="1" indent="0">
+              <a:lnSpc>
+                <a:spcPct val="50000"/>
+              </a:lnSpc>
+              <a:buNone/>
+            </a:pPr>
+            <a:r>
+              <a:rPr lang="en-US" altLang="ko-KR" sz="1000" dirty="0">
+                <a:solidFill>
+                  <a:srgbClr val="00B050"/>
+                </a:solidFill>
+              </a:rPr>
+              <a:t>    &lt;button</a:t>
+            </a:r>
+            <a:r>
+              <a:rPr lang="ko-KR" altLang="en-US" sz="1000" dirty="0">
+                <a:solidFill>
+                  <a:srgbClr val="00B050"/>
+                </a:solidFill>
+              </a:rPr>
+              <a:t> </a:t>
+            </a:r>
+            <a:r>
+              <a:rPr lang="en-US" altLang="ko-KR" sz="1000" dirty="0">
+                <a:solidFill>
+                  <a:srgbClr val="00B050"/>
+                </a:solidFill>
+              </a:rPr>
+              <a:t>@click=“GoMenu(‘/home’)”&gt;</a:t>
+            </a:r>
+          </a:p>
+          <a:p>
+            <a:pPr marL="342900" lvl="1" indent="0">
+              <a:lnSpc>
+                <a:spcPct val="50000"/>
+              </a:lnSpc>
+              <a:buNone/>
+            </a:pPr>
+            <a:r>
               <a:rPr lang="en-US" altLang="ko-KR" sz="1000" dirty="0"/>
               <a:t>  &lt;</a:t>
             </a:r>
@@ -4391,6 +4477,223 @@
             </a:r>
           </a:p>
           <a:p>
+            <a:pPr marL="342900" lvl="1" indent="0">
+              <a:lnSpc>
+                <a:spcPct val="50000"/>
+              </a:lnSpc>
+              <a:buNone/>
+            </a:pPr>
+            <a:endParaRPr lang="en-US" altLang="ko-KR" sz="1000" dirty="0"/>
+          </a:p>
+          <a:p>
+            <a:pPr marL="342900" lvl="1" indent="0">
+              <a:lnSpc>
+                <a:spcPct val="50000"/>
+              </a:lnSpc>
+              <a:buNone/>
+            </a:pPr>
+            <a:r>
+              <a:rPr lang="en-US" altLang="ko-KR" sz="1000" dirty="0">
+                <a:solidFill>
+                  <a:srgbClr val="00B050"/>
+                </a:solidFill>
+              </a:rPr>
+              <a:t>&lt;script&gt;</a:t>
+            </a:r>
+          </a:p>
+          <a:p>
+            <a:pPr marL="342900" lvl="1" indent="0">
+              <a:lnSpc>
+                <a:spcPct val="50000"/>
+              </a:lnSpc>
+              <a:buNone/>
+            </a:pPr>
+            <a:r>
+              <a:rPr lang="en-US" altLang="ko-KR" sz="1000" dirty="0">
+                <a:solidFill>
+                  <a:srgbClr val="00B050"/>
+                </a:solidFill>
+              </a:rPr>
+              <a:t>export default</a:t>
+            </a:r>
+          </a:p>
+          <a:p>
+            <a:pPr marL="342900" lvl="1" indent="0">
+              <a:lnSpc>
+                <a:spcPct val="50000"/>
+              </a:lnSpc>
+              <a:buNone/>
+            </a:pPr>
+            <a:r>
+              <a:rPr lang="en-US" altLang="ko-KR" sz="1000" dirty="0">
+                <a:solidFill>
+                  <a:srgbClr val="00B050"/>
+                </a:solidFill>
+              </a:rPr>
+              <a:t>{</a:t>
+            </a:r>
+          </a:p>
+          <a:p>
+            <a:pPr marL="342900" lvl="1" indent="0">
+              <a:lnSpc>
+                <a:spcPct val="50000"/>
+              </a:lnSpc>
+              <a:buNone/>
+            </a:pPr>
+            <a:r>
+              <a:rPr lang="en-US" altLang="ko-KR" sz="1000" dirty="0">
+                <a:solidFill>
+                  <a:srgbClr val="00B050"/>
+                </a:solidFill>
+              </a:rPr>
+              <a:t>	methods: {</a:t>
+            </a:r>
+          </a:p>
+          <a:p>
+            <a:pPr marL="342900" lvl="1" indent="0">
+              <a:lnSpc>
+                <a:spcPct val="50000"/>
+              </a:lnSpc>
+              <a:buNone/>
+            </a:pPr>
+            <a:r>
+              <a:rPr lang="en-US" altLang="ko-KR" sz="1000" dirty="0">
+                <a:solidFill>
+                  <a:srgbClr val="00B050"/>
+                </a:solidFill>
+              </a:rPr>
+              <a:t>	    </a:t>
+            </a:r>
+            <a:r>
+              <a:rPr lang="en-US" altLang="ko-KR" sz="1000" dirty="0" err="1">
+                <a:solidFill>
+                  <a:srgbClr val="00B050"/>
+                </a:solidFill>
+              </a:rPr>
+              <a:t>GoMenu</a:t>
+            </a:r>
+            <a:r>
+              <a:rPr lang="en-US" altLang="ko-KR" sz="1000" dirty="0">
+                <a:solidFill>
+                  <a:srgbClr val="00B050"/>
+                </a:solidFill>
+              </a:rPr>
+              <a:t>(path)</a:t>
+            </a:r>
+          </a:p>
+          <a:p>
+            <a:pPr marL="342900" lvl="1" indent="0">
+              <a:lnSpc>
+                <a:spcPct val="50000"/>
+              </a:lnSpc>
+              <a:buNone/>
+            </a:pPr>
+            <a:r>
+              <a:rPr lang="en-US" altLang="ko-KR" sz="1000" dirty="0">
+                <a:solidFill>
+                  <a:srgbClr val="00B050"/>
+                </a:solidFill>
+              </a:rPr>
+              <a:t>	    {</a:t>
+            </a:r>
+          </a:p>
+          <a:p>
+            <a:pPr marL="342900" lvl="1" indent="0">
+              <a:lnSpc>
+                <a:spcPct val="50000"/>
+              </a:lnSpc>
+              <a:buNone/>
+            </a:pPr>
+            <a:r>
+              <a:rPr lang="en-US" altLang="ko-KR" sz="1000" dirty="0">
+                <a:solidFill>
+                  <a:srgbClr val="00B050"/>
+                </a:solidFill>
+              </a:rPr>
+              <a:t>	        this.$</a:t>
+            </a:r>
+            <a:r>
+              <a:rPr lang="en-US" altLang="ko-KR" sz="1000" dirty="0" err="1">
+                <a:solidFill>
+                  <a:srgbClr val="00B050"/>
+                </a:solidFill>
+              </a:rPr>
+              <a:t>router.push</a:t>
+            </a:r>
+            <a:r>
+              <a:rPr lang="en-US" altLang="ko-KR" sz="1000" dirty="0">
+                <a:solidFill>
+                  <a:srgbClr val="00B050"/>
+                </a:solidFill>
+              </a:rPr>
+              <a:t>(path);</a:t>
+            </a:r>
+          </a:p>
+          <a:p>
+            <a:pPr marL="342900" lvl="1" indent="0">
+              <a:lnSpc>
+                <a:spcPct val="50000"/>
+              </a:lnSpc>
+              <a:buNone/>
+            </a:pPr>
+            <a:r>
+              <a:rPr lang="en-US" altLang="ko-KR" sz="1000" dirty="0">
+                <a:solidFill>
+                  <a:srgbClr val="00B050"/>
+                </a:solidFill>
+              </a:rPr>
+              <a:t>	    }</a:t>
+            </a:r>
+          </a:p>
+          <a:p>
+            <a:pPr marL="342900" lvl="1" indent="0">
+              <a:lnSpc>
+                <a:spcPct val="50000"/>
+              </a:lnSpc>
+              <a:buNone/>
+            </a:pPr>
+            <a:r>
+              <a:rPr lang="en-US" altLang="ko-KR" sz="1000" dirty="0">
+                <a:solidFill>
+                  <a:srgbClr val="00B050"/>
+                </a:solidFill>
+              </a:rPr>
+              <a:t>	}</a:t>
+            </a:r>
+          </a:p>
+          <a:p>
+            <a:pPr marL="342900" lvl="1" indent="0">
+              <a:lnSpc>
+                <a:spcPct val="50000"/>
+              </a:lnSpc>
+              <a:buNone/>
+            </a:pPr>
+            <a:r>
+              <a:rPr lang="en-US" altLang="ko-KR" sz="1000" dirty="0">
+                <a:solidFill>
+                  <a:srgbClr val="00B050"/>
+                </a:solidFill>
+              </a:rPr>
+              <a:t>}</a:t>
+            </a:r>
+          </a:p>
+          <a:p>
+            <a:pPr marL="342900" lvl="1" indent="0">
+              <a:lnSpc>
+                <a:spcPct val="50000"/>
+              </a:lnSpc>
+              <a:buNone/>
+            </a:pPr>
+            <a:r>
+              <a:rPr lang="en-US" altLang="ko-KR" sz="1000" dirty="0">
+                <a:solidFill>
+                  <a:srgbClr val="00B050"/>
+                </a:solidFill>
+              </a:rPr>
+              <a:t>&lt;/script&gt;</a:t>
+            </a:r>
+          </a:p>
+          <a:p>
             <a:pPr marL="0" indent="0">
               <a:lnSpc>
                 <a:spcPct val="50000"/>
@@ -4456,12 +4759,34 @@
             </a:pPr>
             <a:r>
               <a:rPr lang="fr-FR" altLang="ko-KR" sz="1000" dirty="0"/>
-              <a:t>import router from '@/router/index.js'</a:t>
+              <a:t>import router from '@/router/index.js’    </a:t>
+            </a:r>
+            <a:r>
+              <a:rPr lang="fr-FR" altLang="ko-KR" sz="1000" dirty="0">
+                <a:solidFill>
+                  <a:schemeClr val="bg1">
+                    <a:lumMod val="65000"/>
+                  </a:schemeClr>
+                </a:solidFill>
+              </a:rPr>
+              <a:t>// import router from '@/router'</a:t>
             </a:r>
             <a:br>
-              <a:rPr lang="fr-FR" altLang="ko-KR" sz="1000" dirty="0"/>
+              <a:rPr lang="fr-FR" altLang="ko-KR" sz="1000" dirty="0">
+                <a:solidFill>
+                  <a:schemeClr val="bg1">
+                    <a:lumMod val="65000"/>
+                  </a:schemeClr>
+                </a:solidFill>
+              </a:rPr>
             </a:br>
-            <a:endParaRPr lang="fr-FR" altLang="ko-KR" sz="1000" dirty="0"/>
+            <a:endParaRPr lang="fr-FR" altLang="ko-KR" sz="1000" dirty="0">
+              <a:solidFill>
+                <a:schemeClr val="bg1">
+                  <a:lumMod val="65000"/>
+                </a:schemeClr>
+              </a:solidFill>
+            </a:endParaRPr>
           </a:p>
           <a:p>
             <a:pPr marL="342900" lvl="1" indent="0">

</xml_diff>